<commit_message>
presentation v5: drop 4.6 from slides; show only Opus 4.7
Slides previously kept 'Claude Code (Opus 4.6 / 4.7)' to record build
history. User wants the deck to show only the current model — slide 12
'Built with' row is now 'Claude Code (Opus 4.7) · Codex GPT-5.5'.
Slide 9 bottom strip and conclusion bullet on slide 11 also flip to
single-version. Speaker notes follow.

Verified: zero '4.6' strings remain in the rebuilt pptx XML.
</commit_message>
<xml_diff>
--- a/docs/capstone_presentation_v5.pptx
+++ b/docs/capstone_presentation_v5.pptx
@@ -841,7 +841,7 @@
           </a:p>
           <a:p>
             <a:r>
-              <a:t>- Pair-programming:  Claude Code agent on Opus 4.6 and 4.7 across the 12-week build.</a:t>
+              <a:t>- Pair-programming:  Claude Code agent on Opus 4.7 across the build.</a:t>
             </a:r>
           </a:p>
           <a:p>
@@ -6308,8 +6308,8 @@
                   <a:srgbClr val="FFFFFF"/>
                 </a:solidFill>
               </a:rPr>
-              <a:t>✓  Multi-model workflow disclosed:
-    Opus 4.6 + 4.7 build · Codex 5.5 review</a:t>
+              <a:t>✓  AI tools disclosed:
+    Claude Opus 4.7 · Codex 5.5 review</a:t>
             </a:r>
           </a:p>
         </p:txBody>
@@ -7116,7 +7116,7 @@
                   <a:srgbClr val="FFFFFF"/>
                 </a:solidFill>
               </a:rPr>
-              <a:t>Claude Code (Opus 4.6 / 4.7)  ·  Codex GPT-5.5  (independent validation)</a:t>
+              <a:t>Claude Code (Opus 4.7)  ·  Codex GPT-5.5  (independent validation)</a:t>
             </a:r>
           </a:p>
         </p:txBody>
@@ -22757,7 +22757,7 @@
                   <a:srgbClr val="CADCFC"/>
                 </a:solidFill>
               </a:rPr>
-              <a:t>AI tooling:  Runtime  Claude Opus 4.7   ·   Build  Claude Code (Opus 4.6 / 4.7)   ·   Independent validation  Codex GPT-5.5</a:t>
+              <a:t>AI tooling:  Runtime  Claude Opus 4.7   ·   Build  Claude Code (Opus 4.7)   ·   Independent validation  Codex GPT-5.5</a:t>
             </a:r>
           </a:p>
         </p:txBody>

</xml_diff>

<commit_message>
presentation v5: honest framing of user-testing scope
User clarified that informal user testing did happen (family, friends,
classmates) — just not a large-scale formal study. The previous slide
text said 'No formal user study — heuristic evaluation only', which
undersold the actual evaluation.

Slide 11 limitation: 'No formal user study — heuristic evaluation only'
  -> 'Small-scale user testing — family, friends, classmates only'

Slide 10 footer caveat: 'Heuristic self-assessment against the seven
capability gaps in our evaluation · formal user study is future work'
  -> 'Self-evaluation + small-scale user testing (family · friends ·
     classmates) · formal study is future work'

Future Work column unchanged — 'Formal user study (SUS, task
completion time)' still pairs naturally with the new limitation
framing as the natural next step.
</commit_message>
<xml_diff>
--- a/docs/capstone_presentation_v5.pptx
+++ b/docs/capstone_presentation_v5.pptx
@@ -5471,7 +5471,7 @@
                   <a:srgbClr val="CADCFC"/>
                 </a:solidFill>
               </a:rPr>
-              <a:t>Heuristic self-assessment against the seven capability gaps in our evaluation  ·  formal user study is future work (see Slide 11)</a:t>
+              <a:t>Self-evaluation + small-scale user testing (family · friends · classmates)  ·  formal study is future work (see Slide 11)</a:t>
             </a:r>
           </a:p>
         </p:txBody>
@@ -6063,8 +6063,8 @@
                   <a:srgbClr val="FFFFFF"/>
                 </a:solidFill>
               </a:rPr>
-              <a:t>⚠  No formal user study —
-    heuristic evaluation only</a:t>
+              <a:t>⚠  Small-scale user testing —
+    family, friends, classmates only</a:t>
             </a:r>
           </a:p>
         </p:txBody>

</xml_diff>